<commit_message>
Present Pantrix as a standalone project; rename the checklist to a delivery checklist
</commit_message>
<xml_diff>
--- a/demo/presentation.pptx
+++ b/demo/presentation.pptx
@@ -574,7 +574,7 @@
           <a:p>
             <a:r>
               <a:rPr lang="en-US" dirty="0"/>
-              <a:t>Hi, I am Dhruv Sharma (GitHub Spiritsfuse). This is Pantrix, my DevSecOps capstone. Pantrix helps a community food bank track donated stock and its expiry dates so food goes out before it spoils. In this talk I cover the app, the architecture, testing, Docker, the CI/CD pipeline with security gates, Terraform for AWS, Kubernetes with Helm and Argo CD, observability, and the troubleshooting drills. After the slides I switch to a live walkthrough.</a:t>
+              <a:t>Hi, I am Dhruv Sharma (GitHub Spiritsfuse). This is Pantrix, my DevSecOps project. Pantrix helps a community food bank track donated stock and its expiry dates so food goes out before it spoils. In this talk I cover the app, the architecture, testing, Docker, the CI/CD pipeline with security gates, Terraform for AWS, Kubernetes with Helm and Argo CD, observability, and the troubleshooting drills. After the slides I switch to a live walkthrough.</a:t>
             </a:r>
             <a:endParaRPr lang="en-US" dirty="0"/>
           </a:p>
@@ -2169,7 +2169,7 @@
                   <a:schemeClr val="tx2"/>
                 </a:solidFill>
               </a:rPr>
-              <a:t>Pantrix · Dhruv Sharma (@Spiritsfuse) · DevSecOps capstone</a:t>
+              <a:t>Pantrix · Dhruv Sharma (@Spiritsfuse) · DevSecOps project</a:t>
             </a:r>
             <a:endParaRPr lang="en-US" sz="1000" dirty="0"/>
           </a:p>
@@ -2739,7 +2739,7 @@
                   <a:srgbClr val="C48A0C"/>
                 </a:solidFill>
               </a:rPr>
-              <a:t>DevSecOps capstone · Dhruv Sharma · @Spiritsfuse · github.com/spiritsfuse</a:t>
+              <a:t>DevSecOps project · Dhruv Sharma · @Spiritsfuse · github.com/spiritsfuse</a:t>
             </a:r>
             <a:endParaRPr lang="en-US" sz="2000" dirty="0"/>
           </a:p>

</xml_diff>

<commit_message>
Keep the capstone wording consistent across the deck, captions and video script
</commit_message>
<xml_diff>
--- a/demo/presentation.pptx
+++ b/demo/presentation.pptx
@@ -574,7 +574,7 @@
           <a:p>
             <a:r>
               <a:rPr lang="en-US" dirty="0"/>
-              <a:t>Hi, I am Dhruv Sharma (GitHub Spiritsfuse). This is Pantrix, my DevSecOps project. Pantrix helps a community food bank track donated stock and its expiry dates so food goes out before it spoils. In this talk I cover the app, the architecture, testing, Docker, the CI/CD pipeline with security gates, Terraform for AWS, Kubernetes with Helm and Argo CD, observability, and the troubleshooting drills. After the slides I switch to a live walkthrough.</a:t>
+              <a:t>Hi, I am Dhruv Sharma (GitHub Spiritsfuse). This is Pantrix, my DevSecOps capstone. Pantrix helps a community food bank track donated stock and its expiry dates so food goes out before it spoils. In this talk I cover the app, the architecture, testing, Docker, the CI/CD pipeline with security gates, Terraform for AWS, Kubernetes with Helm and Argo CD, observability, and the troubleshooting drills. After the slides I switch to a live walkthrough.</a:t>
             </a:r>
             <a:endParaRPr lang="en-US" dirty="0"/>
           </a:p>
@@ -2169,7 +2169,7 @@
                   <a:schemeClr val="tx2"/>
                 </a:solidFill>
               </a:rPr>
-              <a:t>Pantrix · Dhruv Sharma (@Spiritsfuse) · DevSecOps project</a:t>
+              <a:t>Pantrix · Dhruv Sharma (@Spiritsfuse) · DevSecOps capstone</a:t>
             </a:r>
             <a:endParaRPr lang="en-US" sz="1000" dirty="0"/>
           </a:p>
@@ -2739,7 +2739,7 @@
                   <a:srgbClr val="C48A0C"/>
                 </a:solidFill>
               </a:rPr>
-              <a:t>DevSecOps project · Dhruv Sharma · @Spiritsfuse · github.com/spiritsfuse</a:t>
+              <a:t>DevSecOps capstone · Dhruv Sharma · @Spiritsfuse · github.com/spiritsfuse</a:t>
             </a:r>
             <a:endParaRPr lang="en-US" sz="2000" dirty="0"/>
           </a:p>

</xml_diff>

<commit_message>
Record the real AWS apply and destroy, the GitHub run logs, and a rebuilt video and deck
- Real terraform plan, apply (two attempts: the first stopped on a Free-plan
  node type), AWS Console proof, kubectl output and destroy, with a cleanup check.
- Real GitHub Actions logs: pytest, Trivy, GHCR push, kind smoke test, artifacts.
- Video: CI and Terraform parts replaced with the real runs; deck and PDF
  regenerated; splice, card and PPTX-text tools added under scripts/video.
</commit_message>
<xml_diff>
--- a/demo/presentation.pptx
+++ b/demo/presentation.pptx
@@ -750,7 +750,7 @@
           <a:p>
             <a:r>
               <a:rPr lang="en-US" dirty="0"/>
-              <a:t>The Terraform creates a VPC with two public and two private subnets across two availability zones in ap-south-1, a single NAT gateway, and an EKS 1.35 cluster with one managed node group in the private subnets, KMS-encrypted secrets and control-plane logs. To be clear: I could not provision it in real AWS because there were no valid credentials on this machine, so there are no AWS Console screenshots. Instead I ran the same code against Moto, a local AWS API emulator: plan resolves 62 resources, apply created 54 before reaching EKS add-on APIs that Moto does not implement, and destroy removed all 54.</a:t>
+              <a:t>The Terraform creates a VPC with two public and two private subnets across two availability zones in ap-south-1, a single NAT gateway, and an EKS 1.35 cluster with one managed node group in the private subnets, KMS-encrypted secrets and control-plane logs. I ran it against a real AWS account: the plan had 62 resources and the apply created them. The first apply stopped at the node group because the account is on the Free plan and rejects t3.medium; with an eligible type the two nodes became Ready, and I captured the Console pages and kubectl output. Then I ran terraform destroy: 62 destroyed and nothing left.</a:t>
             </a:r>
             <a:endParaRPr lang="en-US" dirty="0"/>
           </a:p>
@@ -926,7 +926,7 @@
           <a:p>
             <a:r>
               <a:rPr lang="en-US" dirty="0"/>
-              <a:t>Build and deployment are separate. CI only builds, scans and publishes images. Deployment is a Git commit that changes the image tag in the GitOps values file, and Argo CD reconciles the cluster to it with prune and self-heal. I promoted a real fix this way and Argo CD went to Synced and Healthy at that commit. Until the GitHub repository exists, Argo CD reads from a Git server inside the cluster.</a:t>
+              <a:t>Build and deployment are separate. CI only builds, scans and publishes images. Deployment is a Git commit that changes the image tag in the GitOps values file, and Argo CD reconciles the cluster to it with prune and self-heal. I promoted a real fix this way and Argo CD went to Synced and Healthy at that commit. On GitHub the promote workflow commits the same change, for example d311f11; the local demo cluster reads from a Git server inside it.</a:t>
             </a:r>
             <a:endParaRPr lang="en-US" dirty="0"/>
           </a:p>
@@ -1190,7 +1190,7 @@
           <a:p>
             <a:r>
               <a:rPr lang="en-US" dirty="0"/>
-              <a:t>To wrap up: the biggest lessons were fixing the cause of a scanner finding instead of suppressing it, the difference between liveness and readiness, separating build from deployment with GitOps, and how much drills reveal. Everything on the middle column is verified with real output in docs/evidence. Two things depend on external access: the first GitHub Actions run with GHCR packages, and a real AWS apply, which needs credentials and cost approval. Thank you. Now the live walkthrough.</a:t>
+              <a:t>To wrap up: the biggest lessons were fixing the cause of a scanner finding instead of suppressing it, the difference between liveness and readiness, separating build from deployment with GitOps, and how much drills reveal. Everything on the middle column is verified with real output in docs/evidence. The GitHub Actions run with its registry packages, and the AWS apply and destroy, are verified too. Thank you. Now the live walkthrough.</a:t>
             </a:r>
             <a:endParaRPr lang="en-US" dirty="0"/>
           </a:p>
@@ -1454,7 +1454,7 @@
           <a:p>
             <a:r>
               <a:rPr lang="en-US" dirty="0"/>
-              <a:t>The stack follows the course reference: React and Vite, FastAPI, PostgreSQL with SQLAlchemy and Alembic, pytest, Docker, GitHub Actions, Trivy, GHCR, Terraform for AWS VPC and EKS, Kubernetes with Helm, Ingress and HPA, Prometheus and Grafana. On top of that I added Gitleaks, SBOMs, provenance attestations, Argo CD for GitOps, network policies and troubleshooting drills.</a:t>
+              <a:t>The stack follows a standard reference architecture: React and Vite, FastAPI, PostgreSQL with SQLAlchemy and Alembic, pytest, Docker, GitHub Actions, Trivy, GHCR, Terraform for AWS VPC and EKS, Kubernetes with Helm, Ingress and HPA, Prometheus and Grafana. On top of that I added Gitleaks, SBOMs, provenance attestations, Argo CD for GitOps, network policies and troubleshooting drills.</a:t>
             </a:r>
             <a:endParaRPr lang="en-US" dirty="0"/>
           </a:p>
@@ -1542,7 +1542,7 @@
           <a:p>
             <a:r>
               <a:rPr lang="en-US" dirty="0"/>
-              <a:t>Traffic enters through ingress-nginx. Slash goes to the frontend Nginx pods, slash api goes straight to the FastAPI pods. The backend runs Alembic in an init container, talks to PostgreSQL in a StatefulSet with a persistent volume, and only backend pods may reach the database because of a NetworkPolicy. Prometheus scrapes every backend pod through a ServiceMonitor and Grafana shows the dashboard. A second copy of the same chart in pantrix-gitops is owned by Argo CD, which watches a Git server in the cluster until the GitHub repository exists.</a:t>
+              <a:t>Traffic enters through ingress-nginx. Slash goes to the frontend Nginx pods, slash api goes straight to the FastAPI pods. The backend runs Alembic in an init container, talks to PostgreSQL in a StatefulSet with a persistent volume, and only backend pods may reach the database because of a NetworkPolicy. Prometheus scrapes every backend pod through a ServiceMonitor and Grafana shows the dashboard. A second copy of the same chart in pantrix-gitops is owned by Argo CD, which watches a Git server in the cluster for the local rehearsal.</a:t>
             </a:r>
             <a:endParaRPr lang="en-US" dirty="0"/>
           </a:p>
@@ -1894,7 +1894,7 @@
           <a:p>
             <a:r>
               <a:rPr lang="en-US" dirty="0"/>
-              <a:t>The pipeline triggers on every push to main. Four gates run in parallel: backend tests and SAST, frontend lint, tests and build, a Gitleaks scan of the full history, and infrastructure checks. Only if all pass are the two images built, checked for a non-root user, scanned by Trivy, given an SBOM, and pushed to GHCR tagged with the commit SHA, never latest. A kind job rehearses the Helm deploy through the Ingress, and promote.yml commits the new tag for Argo CD. Honest status: the workflows are validated with actionlint and every gate ran locally; the first real GitHub run happens once the repository is pushed.</a:t>
+              <a:t>The pipeline triggers on every push to main. Four gates run in parallel: backend tests and SAST, frontend lint, tests and build, a Gitleaks scan of the full history, and infrastructure checks. Only if all pass are the two images built, checked for a non-root user, scanned by Trivy, given an SBOM, and pushed to GHCR tagged with the commit SHA, never latest. A kind job rehearses the Helm deploy through the Ingress, and promote.yml commits the new tag for Argo CD. Status: the latest run on GitHub is green. Every gate, both Trivy scans, the registry push with provenance and the kind deploy passed, and promote.yml then committed the SHA for Argo CD.</a:t>
             </a:r>
             <a:endParaRPr lang="en-US" dirty="0"/>
           </a:p>
@@ -3519,7 +3519,7 @@
                   <a:schemeClr val="tx1"/>
                 </a:solidFill>
               </a:rPr>
-              <a:t>Terraform: VPC and EKS as code (real AWS run pending)</a:t>
+              <a:t>Terraform: VPC and EKS as code, applied and destroyed on real AWS</a:t>
             </a:r>
             <a:endParaRPr lang="en-US" sz="3400" dirty="0"/>
           </a:p>
@@ -3652,7 +3652,7 @@
                   <a:schemeClr val="tx2"/>
                 </a:solidFill>
               </a:rPr>
-              <a:t>resources in terraform plan (Moto emulator)</a:t>
+              <a:t>resources in terraform plan (real AWS)</a:t>
             </a:r>
             <a:endParaRPr lang="en-US" sz="1300" dirty="0"/>
           </a:p>
@@ -3691,7 +3691,7 @@
                 <a:ea typeface="Cambria" pitchFamily="34" charset="-122"/>
                 <a:cs typeface="Cambria" pitchFamily="34" charset="-120"/>
               </a:rPr>
-              <a:t>54 / 62</a:t>
+              <a:t>62 / 62</a:t>
             </a:r>
             <a:endParaRPr lang="en-US" sz="4000" dirty="0"/>
           </a:p>
@@ -3727,7 +3727,7 @@
                   <a:schemeClr val="tx2"/>
                 </a:solidFill>
               </a:rPr>
-              <a:t>created by apply in the emulator; EKS add-on APIs missing in Moto</a:t>
+              <a:t>created by two applies; the first node group needed a Free-plan eligible type</a:t>
             </a:r>
             <a:endParaRPr lang="en-US" sz="1300" dirty="0"/>
           </a:p>
@@ -3766,7 +3766,7 @@
                 <a:ea typeface="Cambria" pitchFamily="34" charset="-122"/>
                 <a:cs typeface="Cambria" pitchFamily="34" charset="-120"/>
               </a:rPr>
-              <a:t>54</a:t>
+              <a:t>62</a:t>
             </a:r>
             <a:endParaRPr lang="en-US" sz="4000" dirty="0"/>
           </a:p>
@@ -3802,7 +3802,7 @@
                   <a:schemeClr val="tx2"/>
                 </a:solidFill>
               </a:rPr>
-              <a:t>destroyed by terraform destroy (emulator)</a:t>
+              <a:t>destroyed by terraform destroy; nothing left</a:t>
             </a:r>
             <a:endParaRPr lang="en-US" sz="1300" dirty="0"/>
           </a:p>
@@ -3865,7 +3865,7 @@
                   <a:schemeClr val="accent6"/>
                 </a:solidFill>
               </a:rPr>
-              <a:t>Not provisioned in a real AWS account: this computer has no valid AWS credentials (terraform plan stops at STS InvalidClientTokenId). No AWS Console screenshots exist. fmt, init and validate pass; Trivy IaC scan passes.</a:t>
+              <a:t>Provisioned in a real AWS account (ap-south-1), then destroyed: two m7i-flex.large nodes Ready on EKS 1.35, with Console and kubectl proof. The first apply stopped because t3.medium is not Free-plan eligible. fmt, init and validate pass; Trivy IaC scan passes.</a:t>
             </a:r>
             <a:endParaRPr lang="en-US" sz="1350" dirty="0"/>
           </a:p>
@@ -4939,7 +4939,7 @@
                   <a:schemeClr val="tx2"/>
                 </a:solidFill>
               </a:rPr>
-              <a:t>Until the GitHub repo exists, Argo CD watches an in-cluster git daemon; no Git remote is configured.</a:t>
+              <a:t>CI pushes to GitHub (ci-cd #6, then promote.yml). The local demo cluster watches an in-cluster git daemon.</a:t>
             </a:r>
             <a:endParaRPr lang="en-US" sz="1100" dirty="0"/>
           </a:p>
@@ -7162,7 +7162,7 @@
                   <a:schemeClr val="bg2"/>
                 </a:solidFill>
               </a:rPr>
-              <a:t>What I learned, what is verified, what is pending</a:t>
+              <a:t>What I learned and what is verified</a:t>
             </a:r>
             <a:endParaRPr lang="en-US" sz="3400" dirty="0"/>
           </a:p>
@@ -7467,7 +7467,7 @@
                 <a:ea typeface="Cambria" pitchFamily="34" charset="-122"/>
                 <a:cs typeface="Cambria" pitchFamily="34" charset="-120"/>
               </a:rPr>
-              <a:t>Pending (external access)</a:t>
+              <a:t>Also verified</a:t>
             </a:r>
             <a:endParaRPr lang="en-US" sz="2000" dirty="0"/>
           </a:p>
@@ -7507,7 +7507,7 @@
                   <a:srgbClr val="FBF6EC"/>
                 </a:solidFill>
               </a:rPr>
-              <a:t>First GitHub Actions run and GHCR packages (after the repo is pushed)</a:t>
+              <a:t>GitHub Actions run green, GHCR packages, GitOps promotion</a:t>
             </a:r>
             <a:endParaRPr lang="en-US" sz="1350" dirty="0"/>
           </a:p>
@@ -7525,7 +7525,7 @@
                   <a:srgbClr val="FBF6EC"/>
                 </a:solidFill>
               </a:rPr>
-              <a:t>Real AWS VPC + EKS apply, Console proof and destroy (needs AWS credentials and approval)</a:t>
+              <a:t>Real AWS VPC + EKS plan, apply, Console proof, destroy</a:t>
             </a:r>
             <a:endParaRPr lang="en-US" sz="1350" dirty="0"/>
           </a:p>

</xml_diff>